<commit_message>
fix: slide decks missed enabling Firestore, plus leftover develop/tutorial refs
- Setup slide never told students to enable Auth/Firestore, only "create
  a project" + "paste config" — the exact gap the markdown docs already
  covered, just missed when the decks were built.
- Several slides still said "PR into develop" and referenced the old
  combined COPY-PASTE-TUTORIAL.md (split into SETUP.md + FEATURE.md
  since then) — leftover from before the git workflow simplification
  and tutorial split.
- Two "firebase deploy" commands were missing the npx firebase-tools
  prefix fix that was already applied everywhere else.
</commit_message>
<xml_diff>
--- a/docs/garage-boilerplate-guide.pptx
+++ b/docs/garage-boilerplate-guide.pptx
@@ -6142,7 +6142,7 @@
                   <a:srgbClr val="334155"/>
                 </a:solidFill>
               </a:rPr>
-              <a:t>Firestore rules don't allow it — add rules, then firebase deploy --only firestore:rules</a:t>
+              <a:t>Firestore rules don't allow it — add rules, then npx firebase-tools deploy --only firestore:rules</a:t>
             </a:r>
           </a:p>
         </p:txBody>
@@ -7024,7 +7024,7 @@
                 </a:solidFill>
                 <a:latin typeface="Courier New"/>
               </a:rPr>
-              <a:t>docs/COPY-PASTE-TUTORIAL.md</a:t>
+              <a:t>docs/COPY-PASTE-SETUP.md · FEATURE.md</a:t>
             </a:r>
             <a:r>
               <a:rPr sz="1800">
@@ -9045,6 +9045,21 @@
                   <a:srgbClr val="334155"/>
                 </a:solidFill>
               </a:rPr>
+              <a:t>Enable Authentication + Firestore Database</a:t>
+            </a:r>
+          </a:p>
+          <a:p>
+            <a:pPr algn="l">
+              <a:spcAft>
+                <a:spcPts val="400"/>
+              </a:spcAft>
+            </a:pPr>
+            <a:r>
+              <a:rPr sz="1500" b="0">
+                <a:solidFill>
+                  <a:srgbClr val="334155"/>
+                </a:solidFill>
+              </a:rPr>
               <a:t>Paste its config values into the root .env</a:t>
             </a:r>
           </a:p>
@@ -10339,7 +10354,7 @@
                   <a:srgbClr val="334155"/>
                 </a:solidFill>
               </a:rPr>
-              <a:t>into develop</a:t>
+              <a:t>into main</a:t>
             </a:r>
           </a:p>
           <a:p>
@@ -11084,7 +11099,7 @@
                   <a:srgbClr val="0F172A"/>
                 </a:solidFill>
               </a:rPr>
-              <a:t>Copy-paste, no AI — docs/COPY-PASTE-TUTORIAL.md</a:t>
+              <a:t>Copy-paste, no AI — docs/COPY-PASTE-SETUP.md + FEATURE.md</a:t>
             </a:r>
           </a:p>
           <a:p>

</xml_diff>